<commit_message>
chore: datasets in DVC, backlog issues, branch protection, deck team name
Adds DVC pointers and provenance for the mine-detection SSS dataset and SeabedObjects-KLSG (local remote, analytics off) and fixes .gitignore so DVC can find pointer files. Records CI verification of the conda environment on Ubuntu and Windows, branch protection on main, the 91 backlog issues, the AI4Shipwrecks licence (CC BY 4.0), S3Simulator local-only use, outreach status and the team name on the idea deck. Updates TODO Phase 1 (25 of 28) and CHANGELOG.
</commit_message>
<xml_diff>
--- a/docs/hackathon/idea-deck/SonarSentinel_SIH2026_Idea_DRAFT.pptx
+++ b/docs/hackathon/idea-deck/SonarSentinel_SIH2026_Idea_DRAFT.pptx
@@ -5717,7 +5717,7 @@
             </a:pPr>
             <a:r>
               <a:rPr lang="en-US" sz="1700"/>
-              <a:t>Team Name (Registered on portal)- &lt;Team Name&gt;</a:t>
+              <a:t>Team Name (Registered on portal)- Vashishta</a:t>
             </a:r>
             <a:endParaRPr lang="en-IN" sz="1700" b="1" dirty="0">
               <a:latin typeface="Arial" panose="020B0604020202020204" pitchFamily="34" charset="0"/>
@@ -6150,15 +6150,15 @@
           </a:fontRef>
         </p:style>
         <p:txBody>
-          <a:bodyPr rtlCol="0" anchor="ctr"/>
+          <a:bodyPr wrap="none" lIns="25400" rIns="25400" rtlCol="0" anchor="ctr"/>
           <a:lstStyle/>
           <a:p>
             <a:pPr algn="ctr"/>
             <a:r>
-              <a:rPr lang="en-US" dirty="0"/>
-              <a:t>Your Team Name</a:t>
-            </a:r>
-            <a:endParaRPr lang="en-IN" dirty="0"/>
+              <a:rPr lang="en-US" sz="1300"/>
+              <a:t>Vashishta</a:t>
+            </a:r>
+            <a:endParaRPr lang="en-IN" sz="1300" dirty="0"/>
           </a:p>
         </p:txBody>
       </p:sp>
@@ -6197,7 +6197,7 @@
           <p:cNvPr id="2" name="TextBox 1">
             <a:extLst>
               <a:ext uri="{FF2B5EF4-FFF2-40B4-BE49-F238E27FC236}">
-                <a16:creationId xmlns:a16="http://schemas.microsoft.com/office/drawing/2014/main" id="{04FE02F4-46A0-07B7-E365-8F286E81CD90}"/>
+                <a16:creationId xmlns:a16="http://schemas.microsoft.com/office/drawing/2014/main" id="{B02C2989-5906-D6AF-B4A1-8D9E478D2FC4}"/>
               </a:ext>
             </a:extLst>
           </p:cNvPr>
@@ -6458,7 +6458,7 @@
           <p:cNvPr id="3" name="Rectangle: Rounded Corners 2">
             <a:extLst>
               <a:ext uri="{FF2B5EF4-FFF2-40B4-BE49-F238E27FC236}">
-                <a16:creationId xmlns:a16="http://schemas.microsoft.com/office/drawing/2014/main" id="{B43194AC-B998-CAC3-5C5C-DC1F9D380343}"/>
+                <a16:creationId xmlns:a16="http://schemas.microsoft.com/office/drawing/2014/main" id="{A53B6A47-C5F4-B914-E1C3-02C214D48C2C}"/>
               </a:ext>
             </a:extLst>
           </p:cNvPr>
@@ -6510,7 +6510,7 @@
           <p:cNvPr id="4" name="TextBox 3">
             <a:extLst>
               <a:ext uri="{FF2B5EF4-FFF2-40B4-BE49-F238E27FC236}">
-                <a16:creationId xmlns:a16="http://schemas.microsoft.com/office/drawing/2014/main" id="{CE321146-9037-1510-82D2-E4C913651BC8}"/>
+                <a16:creationId xmlns:a16="http://schemas.microsoft.com/office/drawing/2014/main" id="{E806FFA9-F444-E05E-2429-98C92BD69AD7}"/>
               </a:ext>
             </a:extLst>
           </p:cNvPr>
@@ -6683,7 +6683,7 @@
           <p:cNvPr id="5" name="Rectangle: Rounded Corners 4">
             <a:extLst>
               <a:ext uri="{FF2B5EF4-FFF2-40B4-BE49-F238E27FC236}">
-                <a16:creationId xmlns:a16="http://schemas.microsoft.com/office/drawing/2014/main" id="{7BFC6D52-46CE-5AE6-52B9-7AF5C420C055}"/>
+                <a16:creationId xmlns:a16="http://schemas.microsoft.com/office/drawing/2014/main" id="{08AAD762-3510-76C1-676C-F15EF090034C}"/>
               </a:ext>
             </a:extLst>
           </p:cNvPr>
@@ -7082,15 +7082,15 @@
           </a:fontRef>
         </p:style>
         <p:txBody>
-          <a:bodyPr rtlCol="0" anchor="ctr"/>
+          <a:bodyPr wrap="none" lIns="25400" rIns="25400" rtlCol="0" anchor="ctr"/>
           <a:lstStyle/>
           <a:p>
             <a:pPr algn="ctr"/>
             <a:r>
-              <a:rPr lang="en-US" dirty="0"/>
-              <a:t>Your Team Name</a:t>
-            </a:r>
-            <a:endParaRPr lang="en-IN" dirty="0"/>
+              <a:rPr lang="en-US" sz="1300"/>
+              <a:t>Vashishta</a:t>
+            </a:r>
+            <a:endParaRPr lang="en-IN" sz="1300" dirty="0"/>
           </a:p>
         </p:txBody>
       </p:sp>
@@ -7129,7 +7129,7 @@
           <p:cNvPr id="2" name="Table 1">
             <a:extLst>
               <a:ext uri="{FF2B5EF4-FFF2-40B4-BE49-F238E27FC236}">
-                <a16:creationId xmlns:a16="http://schemas.microsoft.com/office/drawing/2014/main" id="{721B2CDD-D700-CDE5-9744-C53FB71C1DB8}"/>
+                <a16:creationId xmlns:a16="http://schemas.microsoft.com/office/drawing/2014/main" id="{749CBC1B-180E-B149-3AB0-8FECAFF9ECA0}"/>
               </a:ext>
             </a:extLst>
           </p:cNvPr>
@@ -7139,7 +7139,7 @@
           <p:nvPr>
             <p:extLst>
               <p:ext uri="{D42A27DB-BD31-4B8C-83A1-F6EECF244321}">
-                <p14:modId xmlns:p14="http://schemas.microsoft.com/office/powerpoint/2010/main" val="740267059"/>
+                <p14:modId xmlns:p14="http://schemas.microsoft.com/office/powerpoint/2010/main" val="791693733"/>
               </p:ext>
             </p:extLst>
           </p:nvPr>
@@ -7158,14 +7158,14 @@
                 <a:gridCol w="2159000">
                   <a:extLst>
                     <a:ext uri="{9D8B030D-6E8A-4147-A177-3AD203B41FA5}">
-                      <a16:colId xmlns:a16="http://schemas.microsoft.com/office/drawing/2014/main" val="1548154976"/>
+                      <a16:colId xmlns:a16="http://schemas.microsoft.com/office/drawing/2014/main" val="3281345459"/>
                     </a:ext>
                   </a:extLst>
                 </a:gridCol>
                 <a:gridCol w="9017000">
                   <a:extLst>
                     <a:ext uri="{9D8B030D-6E8A-4147-A177-3AD203B41FA5}">
-                      <a16:colId xmlns:a16="http://schemas.microsoft.com/office/drawing/2014/main" val="336626519"/>
+                      <a16:colId xmlns:a16="http://schemas.microsoft.com/office/drawing/2014/main" val="242274928"/>
                     </a:ext>
                   </a:extLst>
                 </a:gridCol>
@@ -7199,7 +7199,7 @@
                 </a:tc>
                 <a:extLst>
                   <a:ext uri="{0D108BD9-81ED-4DB2-BD59-A6C34878D82A}">
-                    <a16:rowId xmlns:a16="http://schemas.microsoft.com/office/drawing/2014/main" val="3017224431"/>
+                    <a16:rowId xmlns:a16="http://schemas.microsoft.com/office/drawing/2014/main" val="2582042158"/>
                   </a:ext>
                 </a:extLst>
               </a:tr>
@@ -7232,7 +7232,7 @@
                 </a:tc>
                 <a:extLst>
                   <a:ext uri="{0D108BD9-81ED-4DB2-BD59-A6C34878D82A}">
-                    <a16:rowId xmlns:a16="http://schemas.microsoft.com/office/drawing/2014/main" val="3739641747"/>
+                    <a16:rowId xmlns:a16="http://schemas.microsoft.com/office/drawing/2014/main" val="267640221"/>
                   </a:ext>
                 </a:extLst>
               </a:tr>
@@ -7266,7 +7266,7 @@
                 </a:tc>
                 <a:extLst>
                   <a:ext uri="{0D108BD9-81ED-4DB2-BD59-A6C34878D82A}">
-                    <a16:rowId xmlns:a16="http://schemas.microsoft.com/office/drawing/2014/main" val="4063912427"/>
+                    <a16:rowId xmlns:a16="http://schemas.microsoft.com/office/drawing/2014/main" val="1336790835"/>
                   </a:ext>
                 </a:extLst>
               </a:tr>
@@ -7299,7 +7299,7 @@
                 </a:tc>
                 <a:extLst>
                   <a:ext uri="{0D108BD9-81ED-4DB2-BD59-A6C34878D82A}">
-                    <a16:rowId xmlns:a16="http://schemas.microsoft.com/office/drawing/2014/main" val="2164003273"/>
+                    <a16:rowId xmlns:a16="http://schemas.microsoft.com/office/drawing/2014/main" val="3507984981"/>
                   </a:ext>
                 </a:extLst>
               </a:tr>
@@ -7332,7 +7332,7 @@
                 </a:tc>
                 <a:extLst>
                   <a:ext uri="{0D108BD9-81ED-4DB2-BD59-A6C34878D82A}">
-                    <a16:rowId xmlns:a16="http://schemas.microsoft.com/office/drawing/2014/main" val="1119835951"/>
+                    <a16:rowId xmlns:a16="http://schemas.microsoft.com/office/drawing/2014/main" val="2015204842"/>
                   </a:ext>
                 </a:extLst>
               </a:tr>
@@ -7365,7 +7365,7 @@
                 </a:tc>
                 <a:extLst>
                   <a:ext uri="{0D108BD9-81ED-4DB2-BD59-A6C34878D82A}">
-                    <a16:rowId xmlns:a16="http://schemas.microsoft.com/office/drawing/2014/main" val="3892052170"/>
+                    <a16:rowId xmlns:a16="http://schemas.microsoft.com/office/drawing/2014/main" val="4093995938"/>
                   </a:ext>
                 </a:extLst>
               </a:tr>
@@ -7378,7 +7378,7 @@
           <p:cNvPr id="3" name="TextBox 2">
             <a:extLst>
               <a:ext uri="{FF2B5EF4-FFF2-40B4-BE49-F238E27FC236}">
-                <a16:creationId xmlns:a16="http://schemas.microsoft.com/office/drawing/2014/main" id="{3033C43E-9AEA-84F5-730F-65329F74059D}"/>
+                <a16:creationId xmlns:a16="http://schemas.microsoft.com/office/drawing/2014/main" id="{90FDC309-FE72-3998-A2BB-370FE068B277}"/>
               </a:ext>
             </a:extLst>
           </p:cNvPr>
@@ -7430,7 +7430,7 @@
           <p:cNvPr id="4" name="Rectangle: Rounded Corners 3">
             <a:extLst>
               <a:ext uri="{FF2B5EF4-FFF2-40B4-BE49-F238E27FC236}">
-                <a16:creationId xmlns:a16="http://schemas.microsoft.com/office/drawing/2014/main" id="{F0A0F8F4-82F5-C1DE-14BC-95E0B51EF337}"/>
+                <a16:creationId xmlns:a16="http://schemas.microsoft.com/office/drawing/2014/main" id="{CBACE06F-0DE1-03E7-74C1-A86666F8A2BD}"/>
               </a:ext>
             </a:extLst>
           </p:cNvPr>
@@ -7538,7 +7538,7 @@
           <p:cNvPr id="5" name="Arrow: Right 4">
             <a:extLst>
               <a:ext uri="{FF2B5EF4-FFF2-40B4-BE49-F238E27FC236}">
-                <a16:creationId xmlns:a16="http://schemas.microsoft.com/office/drawing/2014/main" id="{62AA71BB-B744-74D0-2C45-A7D668BA1D24}"/>
+                <a16:creationId xmlns:a16="http://schemas.microsoft.com/office/drawing/2014/main" id="{C71060ED-7DAF-BACB-4618-CCAC5F8D38C9}"/>
               </a:ext>
             </a:extLst>
           </p:cNvPr>
@@ -7622,7 +7622,7 @@
           <p:cNvPr id="8" name="Rectangle: Rounded Corners 7">
             <a:extLst>
               <a:ext uri="{FF2B5EF4-FFF2-40B4-BE49-F238E27FC236}">
-                <a16:creationId xmlns:a16="http://schemas.microsoft.com/office/drawing/2014/main" id="{369B8B6D-4649-EBE2-2816-12F973138517}"/>
+                <a16:creationId xmlns:a16="http://schemas.microsoft.com/office/drawing/2014/main" id="{26B9E681-F323-4219-DBD5-93F1DDA0536B}"/>
               </a:ext>
             </a:extLst>
           </p:cNvPr>
@@ -7730,7 +7730,7 @@
           <p:cNvPr id="9" name="Arrow: Right 8">
             <a:extLst>
               <a:ext uri="{FF2B5EF4-FFF2-40B4-BE49-F238E27FC236}">
-                <a16:creationId xmlns:a16="http://schemas.microsoft.com/office/drawing/2014/main" id="{271614E7-6F3A-D38C-8BE6-571629732056}"/>
+                <a16:creationId xmlns:a16="http://schemas.microsoft.com/office/drawing/2014/main" id="{8A7E73A7-358C-5E16-551E-3603679A5125}"/>
               </a:ext>
             </a:extLst>
           </p:cNvPr>
@@ -7814,7 +7814,7 @@
           <p:cNvPr id="13" name="Rectangle: Rounded Corners 12">
             <a:extLst>
               <a:ext uri="{FF2B5EF4-FFF2-40B4-BE49-F238E27FC236}">
-                <a16:creationId xmlns:a16="http://schemas.microsoft.com/office/drawing/2014/main" id="{7AFAD804-64C5-594C-43A7-2D09F8C70BF6}"/>
+                <a16:creationId xmlns:a16="http://schemas.microsoft.com/office/drawing/2014/main" id="{D6C137D1-FAB6-899F-8975-2ADD9069466B}"/>
               </a:ext>
             </a:extLst>
           </p:cNvPr>
@@ -7917,7 +7917,7 @@
           <p:cNvPr id="14" name="Arrow: Right 13">
             <a:extLst>
               <a:ext uri="{FF2B5EF4-FFF2-40B4-BE49-F238E27FC236}">
-                <a16:creationId xmlns:a16="http://schemas.microsoft.com/office/drawing/2014/main" id="{24EF77CD-B303-B9C0-A997-5F1A50868DA4}"/>
+                <a16:creationId xmlns:a16="http://schemas.microsoft.com/office/drawing/2014/main" id="{CD4B0004-3D69-B116-D304-B557D9DF0767}"/>
               </a:ext>
             </a:extLst>
           </p:cNvPr>
@@ -8001,7 +8001,7 @@
           <p:cNvPr id="15" name="Rectangle: Rounded Corners 14">
             <a:extLst>
               <a:ext uri="{FF2B5EF4-FFF2-40B4-BE49-F238E27FC236}">
-                <a16:creationId xmlns:a16="http://schemas.microsoft.com/office/drawing/2014/main" id="{FFA02C6A-3B4A-0D85-5A6B-51B8ABE2ECBD}"/>
+                <a16:creationId xmlns:a16="http://schemas.microsoft.com/office/drawing/2014/main" id="{76B8A814-16D3-1737-1481-68FE787E1AA9}"/>
               </a:ext>
             </a:extLst>
           </p:cNvPr>
@@ -8104,7 +8104,7 @@
           <p:cNvPr id="16" name="Arrow: Right 15">
             <a:extLst>
               <a:ext uri="{FF2B5EF4-FFF2-40B4-BE49-F238E27FC236}">
-                <a16:creationId xmlns:a16="http://schemas.microsoft.com/office/drawing/2014/main" id="{29DEE70E-17AA-8B97-A66F-8A22E6334D38}"/>
+                <a16:creationId xmlns:a16="http://schemas.microsoft.com/office/drawing/2014/main" id="{D25EBC57-AEEA-EE26-ABAE-71F661B422FD}"/>
               </a:ext>
             </a:extLst>
           </p:cNvPr>
@@ -8188,7 +8188,7 @@
           <p:cNvPr id="17" name="Rectangle: Rounded Corners 16">
             <a:extLst>
               <a:ext uri="{FF2B5EF4-FFF2-40B4-BE49-F238E27FC236}">
-                <a16:creationId xmlns:a16="http://schemas.microsoft.com/office/drawing/2014/main" id="{0074301E-E7E5-EEFB-23A5-1A16906C6271}"/>
+                <a16:creationId xmlns:a16="http://schemas.microsoft.com/office/drawing/2014/main" id="{B87F05E8-AD75-A44C-A9D9-AA9AD360F914}"/>
               </a:ext>
             </a:extLst>
           </p:cNvPr>
@@ -8296,7 +8296,7 @@
           <p:cNvPr id="18" name="Arrow: Right 17">
             <a:extLst>
               <a:ext uri="{FF2B5EF4-FFF2-40B4-BE49-F238E27FC236}">
-                <a16:creationId xmlns:a16="http://schemas.microsoft.com/office/drawing/2014/main" id="{C21AEE86-8246-3DDF-A7E1-258061CA0306}"/>
+                <a16:creationId xmlns:a16="http://schemas.microsoft.com/office/drawing/2014/main" id="{C3164907-A370-6601-5D4D-B97CBA8C4F6D}"/>
               </a:ext>
             </a:extLst>
           </p:cNvPr>
@@ -8380,7 +8380,7 @@
           <p:cNvPr id="19" name="Rectangle: Rounded Corners 18">
             <a:extLst>
               <a:ext uri="{FF2B5EF4-FFF2-40B4-BE49-F238E27FC236}">
-                <a16:creationId xmlns:a16="http://schemas.microsoft.com/office/drawing/2014/main" id="{B9F720E8-0316-E69D-53CC-722134204F00}"/>
+                <a16:creationId xmlns:a16="http://schemas.microsoft.com/office/drawing/2014/main" id="{CD9E9F79-CFC2-B58E-7CA9-5BC05DDBA02F}"/>
               </a:ext>
             </a:extLst>
           </p:cNvPr>
@@ -8483,7 +8483,7 @@
           <p:cNvPr id="20" name="TextBox 19">
             <a:extLst>
               <a:ext uri="{FF2B5EF4-FFF2-40B4-BE49-F238E27FC236}">
-                <a16:creationId xmlns:a16="http://schemas.microsoft.com/office/drawing/2014/main" id="{7BC6D0D6-524B-5610-2CE8-91ABC07A1D81}"/>
+                <a16:creationId xmlns:a16="http://schemas.microsoft.com/office/drawing/2014/main" id="{5A626426-132C-C8A8-CC65-02B577DDAC9B}"/>
               </a:ext>
             </a:extLst>
           </p:cNvPr>
@@ -9037,15 +9037,15 @@
           </a:fontRef>
         </p:style>
         <p:txBody>
-          <a:bodyPr rtlCol="0" anchor="ctr"/>
+          <a:bodyPr wrap="none" lIns="25400" rIns="25400" rtlCol="0" anchor="ctr"/>
           <a:lstStyle/>
           <a:p>
             <a:pPr algn="ctr"/>
             <a:r>
-              <a:rPr lang="en-US" dirty="0"/>
-              <a:t>Your Team Name</a:t>
-            </a:r>
-            <a:endParaRPr lang="en-IN" dirty="0"/>
+              <a:rPr lang="en-US" sz="1300"/>
+              <a:t>Vashishta</a:t>
+            </a:r>
+            <a:endParaRPr lang="en-IN" sz="1300" dirty="0"/>
           </a:p>
         </p:txBody>
       </p:sp>
@@ -9084,7 +9084,7 @@
           <p:cNvPr id="2" name="TextBox 1">
             <a:extLst>
               <a:ext uri="{FF2B5EF4-FFF2-40B4-BE49-F238E27FC236}">
-                <a16:creationId xmlns:a16="http://schemas.microsoft.com/office/drawing/2014/main" id="{77BEE4DF-B45F-9A9B-0088-C61A8AB282CB}"/>
+                <a16:creationId xmlns:a16="http://schemas.microsoft.com/office/drawing/2014/main" id="{D1FC2CF8-8089-27D8-1DF3-1F9A9E786A44}"/>
               </a:ext>
             </a:extLst>
           </p:cNvPr>
@@ -9191,7 +9191,7 @@
           <p:cNvPr id="3" name="Table 2">
             <a:extLst>
               <a:ext uri="{FF2B5EF4-FFF2-40B4-BE49-F238E27FC236}">
-                <a16:creationId xmlns:a16="http://schemas.microsoft.com/office/drawing/2014/main" id="{8C42D341-E627-2237-6128-929FD2959058}"/>
+                <a16:creationId xmlns:a16="http://schemas.microsoft.com/office/drawing/2014/main" id="{806007D0-F9CF-3714-B427-FD26221D6B41}"/>
               </a:ext>
             </a:extLst>
           </p:cNvPr>
@@ -9201,7 +9201,7 @@
           <p:nvPr>
             <p:extLst>
               <p:ext uri="{D42A27DB-BD31-4B8C-83A1-F6EECF244321}">
-                <p14:modId xmlns:p14="http://schemas.microsoft.com/office/powerpoint/2010/main" val="1474441977"/>
+                <p14:modId xmlns:p14="http://schemas.microsoft.com/office/powerpoint/2010/main" val="1948187453"/>
               </p:ext>
             </p:extLst>
           </p:nvPr>
@@ -9220,14 +9220,14 @@
                 <a:gridCol w="3810000">
                   <a:extLst>
                     <a:ext uri="{9D8B030D-6E8A-4147-A177-3AD203B41FA5}">
-                      <a16:colId xmlns:a16="http://schemas.microsoft.com/office/drawing/2014/main" val="3362589652"/>
+                      <a16:colId xmlns:a16="http://schemas.microsoft.com/office/drawing/2014/main" val="1758079260"/>
                     </a:ext>
                   </a:extLst>
                 </a:gridCol>
                 <a:gridCol w="7366000">
                   <a:extLst>
                     <a:ext uri="{9D8B030D-6E8A-4147-A177-3AD203B41FA5}">
-                      <a16:colId xmlns:a16="http://schemas.microsoft.com/office/drawing/2014/main" val="1951833905"/>
+                      <a16:colId xmlns:a16="http://schemas.microsoft.com/office/drawing/2014/main" val="184081857"/>
                     </a:ext>
                   </a:extLst>
                 </a:gridCol>
@@ -9261,7 +9261,7 @@
                 </a:tc>
                 <a:extLst>
                   <a:ext uri="{0D108BD9-81ED-4DB2-BD59-A6C34878D82A}">
-                    <a16:rowId xmlns:a16="http://schemas.microsoft.com/office/drawing/2014/main" val="3130263068"/>
+                    <a16:rowId xmlns:a16="http://schemas.microsoft.com/office/drawing/2014/main" val="1964656261"/>
                   </a:ext>
                 </a:extLst>
               </a:tr>
@@ -9295,7 +9295,7 @@
                 </a:tc>
                 <a:extLst>
                   <a:ext uri="{0D108BD9-81ED-4DB2-BD59-A6C34878D82A}">
-                    <a16:rowId xmlns:a16="http://schemas.microsoft.com/office/drawing/2014/main" val="1666587537"/>
+                    <a16:rowId xmlns:a16="http://schemas.microsoft.com/office/drawing/2014/main" val="3300502440"/>
                   </a:ext>
                 </a:extLst>
               </a:tr>
@@ -9330,7 +9330,7 @@
                 </a:tc>
                 <a:extLst>
                   <a:ext uri="{0D108BD9-81ED-4DB2-BD59-A6C34878D82A}">
-                    <a16:rowId xmlns:a16="http://schemas.microsoft.com/office/drawing/2014/main" val="1252668136"/>
+                    <a16:rowId xmlns:a16="http://schemas.microsoft.com/office/drawing/2014/main" val="2634564264"/>
                   </a:ext>
                 </a:extLst>
               </a:tr>
@@ -9365,7 +9365,7 @@
                 </a:tc>
                 <a:extLst>
                   <a:ext uri="{0D108BD9-81ED-4DB2-BD59-A6C34878D82A}">
-                    <a16:rowId xmlns:a16="http://schemas.microsoft.com/office/drawing/2014/main" val="1147677207"/>
+                    <a16:rowId xmlns:a16="http://schemas.microsoft.com/office/drawing/2014/main" val="663761460"/>
                   </a:ext>
                 </a:extLst>
               </a:tr>
@@ -9400,7 +9400,7 @@
                 </a:tc>
                 <a:extLst>
                   <a:ext uri="{0D108BD9-81ED-4DB2-BD59-A6C34878D82A}">
-                    <a16:rowId xmlns:a16="http://schemas.microsoft.com/office/drawing/2014/main" val="68056934"/>
+                    <a16:rowId xmlns:a16="http://schemas.microsoft.com/office/drawing/2014/main" val="238638359"/>
                   </a:ext>
                 </a:extLst>
               </a:tr>
@@ -9435,7 +9435,7 @@
                 </a:tc>
                 <a:extLst>
                   <a:ext uri="{0D108BD9-81ED-4DB2-BD59-A6C34878D82A}">
-                    <a16:rowId xmlns:a16="http://schemas.microsoft.com/office/drawing/2014/main" val="3867454832"/>
+                    <a16:rowId xmlns:a16="http://schemas.microsoft.com/office/drawing/2014/main" val="2985389041"/>
                   </a:ext>
                 </a:extLst>
               </a:tr>
@@ -9862,15 +9862,15 @@
           </a:fontRef>
         </p:style>
         <p:txBody>
-          <a:bodyPr rtlCol="0" anchor="ctr"/>
+          <a:bodyPr wrap="none" lIns="25400" rIns="25400" rtlCol="0" anchor="ctr"/>
           <a:lstStyle/>
           <a:p>
             <a:pPr algn="ctr"/>
             <a:r>
-              <a:rPr lang="en-US" dirty="0"/>
-              <a:t>Your Team Name</a:t>
-            </a:r>
-            <a:endParaRPr lang="en-IN" dirty="0"/>
+              <a:rPr lang="en-US" sz="1300"/>
+              <a:t>Vashishta</a:t>
+            </a:r>
+            <a:endParaRPr lang="en-IN" sz="1300" dirty="0"/>
           </a:p>
         </p:txBody>
       </p:sp>
@@ -9909,7 +9909,7 @@
           <p:cNvPr id="2" name="TextBox 1">
             <a:extLst>
               <a:ext uri="{FF2B5EF4-FFF2-40B4-BE49-F238E27FC236}">
-                <a16:creationId xmlns:a16="http://schemas.microsoft.com/office/drawing/2014/main" id="{872DDDF7-0FDA-4B09-D607-BEAD282D7173}"/>
+                <a16:creationId xmlns:a16="http://schemas.microsoft.com/office/drawing/2014/main" id="{D7E45BDD-5746-426B-10B2-E85CA066CA6E}"/>
               </a:ext>
             </a:extLst>
           </p:cNvPr>
@@ -10016,7 +10016,7 @@
           <p:cNvPr id="3" name="Table 2">
             <a:extLst>
               <a:ext uri="{FF2B5EF4-FFF2-40B4-BE49-F238E27FC236}">
-                <a16:creationId xmlns:a16="http://schemas.microsoft.com/office/drawing/2014/main" id="{DF5F9975-330F-84A8-A97D-4C3B204A08C9}"/>
+                <a16:creationId xmlns:a16="http://schemas.microsoft.com/office/drawing/2014/main" id="{FEE1C92F-4456-A30D-0296-9143B14AB8B5}"/>
               </a:ext>
             </a:extLst>
           </p:cNvPr>
@@ -10026,7 +10026,7 @@
           <p:nvPr>
             <p:extLst>
               <p:ext uri="{D42A27DB-BD31-4B8C-83A1-F6EECF244321}">
-                <p14:modId xmlns:p14="http://schemas.microsoft.com/office/powerpoint/2010/main" val="3910283995"/>
+                <p14:modId xmlns:p14="http://schemas.microsoft.com/office/powerpoint/2010/main" val="3645906404"/>
               </p:ext>
             </p:extLst>
           </p:nvPr>
@@ -10045,14 +10045,14 @@
                 <a:gridCol w="2413000">
                   <a:extLst>
                     <a:ext uri="{9D8B030D-6E8A-4147-A177-3AD203B41FA5}">
-                      <a16:colId xmlns:a16="http://schemas.microsoft.com/office/drawing/2014/main" val="2256715135"/>
+                      <a16:colId xmlns:a16="http://schemas.microsoft.com/office/drawing/2014/main" val="2800710774"/>
                     </a:ext>
                   </a:extLst>
                 </a:gridCol>
                 <a:gridCol w="8763000">
                   <a:extLst>
                     <a:ext uri="{9D8B030D-6E8A-4147-A177-3AD203B41FA5}">
-                      <a16:colId xmlns:a16="http://schemas.microsoft.com/office/drawing/2014/main" val="3447672629"/>
+                      <a16:colId xmlns:a16="http://schemas.microsoft.com/office/drawing/2014/main" val="1411671382"/>
                     </a:ext>
                   </a:extLst>
                 </a:gridCol>
@@ -10086,7 +10086,7 @@
                 </a:tc>
                 <a:extLst>
                   <a:ext uri="{0D108BD9-81ED-4DB2-BD59-A6C34878D82A}">
-                    <a16:rowId xmlns:a16="http://schemas.microsoft.com/office/drawing/2014/main" val="3654340004"/>
+                    <a16:rowId xmlns:a16="http://schemas.microsoft.com/office/drawing/2014/main" val="2498739666"/>
                   </a:ext>
                 </a:extLst>
               </a:tr>
@@ -10120,7 +10120,7 @@
                 </a:tc>
                 <a:extLst>
                   <a:ext uri="{0D108BD9-81ED-4DB2-BD59-A6C34878D82A}">
-                    <a16:rowId xmlns:a16="http://schemas.microsoft.com/office/drawing/2014/main" val="727266397"/>
+                    <a16:rowId xmlns:a16="http://schemas.microsoft.com/office/drawing/2014/main" val="1437735975"/>
                   </a:ext>
                 </a:extLst>
               </a:tr>
@@ -10154,7 +10154,7 @@
                 </a:tc>
                 <a:extLst>
                   <a:ext uri="{0D108BD9-81ED-4DB2-BD59-A6C34878D82A}">
-                    <a16:rowId xmlns:a16="http://schemas.microsoft.com/office/drawing/2014/main" val="2785272851"/>
+                    <a16:rowId xmlns:a16="http://schemas.microsoft.com/office/drawing/2014/main" val="4257457955"/>
                   </a:ext>
                 </a:extLst>
               </a:tr>
@@ -10188,7 +10188,7 @@
                 </a:tc>
                 <a:extLst>
                   <a:ext uri="{0D108BD9-81ED-4DB2-BD59-A6C34878D82A}">
-                    <a16:rowId xmlns:a16="http://schemas.microsoft.com/office/drawing/2014/main" val="604755859"/>
+                    <a16:rowId xmlns:a16="http://schemas.microsoft.com/office/drawing/2014/main" val="2915903819"/>
                   </a:ext>
                 </a:extLst>
               </a:tr>
@@ -10222,7 +10222,7 @@
                 </a:tc>
                 <a:extLst>
                   <a:ext uri="{0D108BD9-81ED-4DB2-BD59-A6C34878D82A}">
-                    <a16:rowId xmlns:a16="http://schemas.microsoft.com/office/drawing/2014/main" val="1368064411"/>
+                    <a16:rowId xmlns:a16="http://schemas.microsoft.com/office/drawing/2014/main" val="946755425"/>
                   </a:ext>
                 </a:extLst>
               </a:tr>
@@ -10256,7 +10256,7 @@
                 </a:tc>
                 <a:extLst>
                   <a:ext uri="{0D108BD9-81ED-4DB2-BD59-A6C34878D82A}">
-                    <a16:rowId xmlns:a16="http://schemas.microsoft.com/office/drawing/2014/main" val="2839265844"/>
+                    <a16:rowId xmlns:a16="http://schemas.microsoft.com/office/drawing/2014/main" val="3909319828"/>
                   </a:ext>
                 </a:extLst>
               </a:tr>
@@ -10664,15 +10664,15 @@
           </a:fontRef>
         </p:style>
         <p:txBody>
-          <a:bodyPr rtlCol="0" anchor="ctr"/>
+          <a:bodyPr wrap="none" lIns="25400" rIns="25400" rtlCol="0" anchor="ctr"/>
           <a:lstStyle/>
           <a:p>
             <a:pPr algn="ctr"/>
             <a:r>
-              <a:rPr lang="en-US" dirty="0"/>
-              <a:t>Your Team Name</a:t>
-            </a:r>
-            <a:endParaRPr lang="en-IN" dirty="0"/>
+              <a:rPr lang="en-US" sz="1300"/>
+              <a:t>Vashishta</a:t>
+            </a:r>
+            <a:endParaRPr lang="en-IN" sz="1300" dirty="0"/>
           </a:p>
         </p:txBody>
       </p:sp>
@@ -10711,7 +10711,7 @@
           <p:cNvPr id="2" name="TextBox 1">
             <a:extLst>
               <a:ext uri="{FF2B5EF4-FFF2-40B4-BE49-F238E27FC236}">
-                <a16:creationId xmlns:a16="http://schemas.microsoft.com/office/drawing/2014/main" id="{6672BA9C-44DE-F8D1-4423-FD24666E1C89}"/>
+                <a16:creationId xmlns:a16="http://schemas.microsoft.com/office/drawing/2014/main" id="{86B62AA4-8ADC-A0DD-8A45-BD8165A19F85}"/>
               </a:ext>
             </a:extLst>
           </p:cNvPr>

</xml_diff>